<commit_message>
Deck: arricchite le fonti scientifiche (CIMA, CMCC, ISS, CNR-IRPI, ReLUIS) nelle slide pertinenti
</commit_message>
<xml_diff>
--- a/static/manuali/presentazione-struttura-sito.pptx
+++ b/static/manuali/presentazione-struttura-sito.pptx
@@ -6323,7 +6323,7 @@
                 </a:solidFill>
                 <a:latin typeface="Liberation Sans"/>
               </a:rPr>
-              <a:t>Fonti: INGV · DPC · ItaliaMeteo · EUMETSAT · ECMWF · Copernicus · ARPA Lazio. Codici colore: Centro Funzionale Regionale del Lazio (ISO 22324).</a:t>
+              <a:t>Fonti: INGV · DPC · ItaliaMeteo · CIMA · EUMETSAT · ECMWF · Copernicus · ARPA Lazio. Codici colore: Centro Funzionale Regionale del Lazio (ISO 22324).</a:t>
             </a:r>
           </a:p>
         </p:txBody>
@@ -8591,7 +8591,7 @@
                 </a:solidFill>
                 <a:latin typeface="Liberation Sans"/>
               </a:rPr>
-              <a:t>Fonti: DPC «Io non rischio» · INGV · ISPRA · CNR.</a:t>
+              <a:t>Fonti: DPC «Io non rischio» · INGV · ISPRA · CNR-IRPI · ReLUIS.</a:t>
             </a:r>
           </a:p>
         </p:txBody>
@@ -36663,7 +36663,7 @@
                 </a:solidFill>
                 <a:latin typeface="Liberation Sans"/>
               </a:rPr>
-              <a:t>DPC · INGV · ISPRA · CNR</a:t>
+              <a:t>DPC · INGV · ISPRA · CNR-IRPI · CIMA · CMCC · ISS</a:t>
             </a:r>
           </a:p>
         </p:txBody>

</xml_diff>